<commit_message>
docs: README, slides e roteiro alinhados aos experimentos revisados
- README: reescrito, com entregáveis, resultados em resumo, contratos do Randoop e seção de contribuições (baseada no git log); corrige a linha de abertura
- Slides e roteiro: números atualizados para os experimentos do PR #1 (1.467 testes do Randoop, 1.500 no total; M1, M2 e M3 detectados com 18, 16 e 4 testes; M4 não detectado); slide 3 alinhado à comparação revisada da resenha (artigos com ênfases diferentes, sem relação de evolução)
- Testes: geradores do jqwik agrupados no topo de FractionPropertiesTest, sem mudança de comportamento
- Scripts do Randoop: formatação do flag --npe-on-non-null-input=ERROR
- tests.md: estatística do P13 de uma execução registrada
- .gitignore: ignora arquivos temporários do PowerPoint (~\$*) e .DS_Store
</commit_message>
<xml_diff>
--- a/apresentacao/apresentacao.pptx
+++ b/apresentacao/apresentacao.pptx
@@ -114,34 +114,34 @@
   <p:extLst>
     <p:ext uri="{521415D9-36F7-43E2-AB2F-B90AF26B5E84}">
       <p14:sectionLst xmlns:p14="http://schemas.microsoft.com/office/powerpoint/2010/main">
-        <p14:section name="Abertura" id="{6bac02e9-5c2a-e9c1-e65d-7c27624f66f4}">
+        <p14:section name="Abertura" id="{6c0ac1dd-07ef-cabc-156a-a73a9d3a8f01}">
           <p14:sldIdLst>
             <p14:sldId id="256"/>
           </p14:sldIdLst>
         </p14:section>
-        <p14:section name="Problema e técnicas" id="{a12f616e-effb-5eaf-100f-d757280987ad}">
+        <p14:section name="Problema e técnicas" id="{887bb75f-ba8b-e8f0-6f2d-de684fe85066}">
           <p14:sldIdLst>
             <p14:sldId id="257"/>
             <p14:sldId id="258"/>
           </p14:sldIdLst>
         </p14:section>
-        <p14:section name="Aplicação" id="{32625466-498d-41b9-74c6-f8cd80a326dd}">
+        <p14:section name="Aplicação" id="{ed340cfb-e25a-377e-fbe8-aa8c2ae38e1c}">
           <p14:sldIdLst>
             <p14:sldId id="259"/>
             <p14:sldId id="260"/>
           </p14:sldIdLst>
         </p14:section>
-        <p14:section name="Resultados" id="{a9b5c6e4-3f9f-0e24-068c-7b39029bce8c}">
+        <p14:section name="Resultados" id="{5ce0dd95-722d-5fe9-80f9-3761e4edb072}">
           <p14:sldIdLst>
             <p14:sldId id="261"/>
           </p14:sldIdLst>
         </p14:section>
-        <p14:section name="Discussão" id="{0357c985-54ec-74a1-765c-f37bd69aeb7c}">
+        <p14:section name="Discussão" id="{d52453f3-6936-ebbd-cee6-8e5a3ac4c2e8}">
           <p14:sldIdLst>
             <p14:sldId id="262"/>
           </p14:sldIdLst>
         </p14:section>
-        <p14:section name="Conclusão" id="{34d56771-4ce6-07bb-1cba-40903a862046}">
+        <p14:section name="Conclusão" id="{2e0dab38-9e00-4096-cf80-d0525913fe8c}">
           <p14:sldIdLst>
             <p14:sldId id="263"/>
           </p14:sldIdLst>
@@ -306,10 +306,10 @@
               <c:numCache>
                 <c:ptCount val="2"/>
                 <c:pt idx="0">
-                  <c:v>3390</c:v>
+                  <c:v>3409</c:v>
                 </c:pt>
                 <c:pt idx="1">
-                  <c:v>559</c:v>
+                  <c:v>539</c:v>
                 </c:pt>
               </c:numCache>
             </c:numRef>
@@ -913,7 +913,7 @@
           <a:p>
             <a:r>
               <a:rPr lang="en-US" dirty="0"/>
-              <a:t>Eduardo (0:50). Em 1997, Fink e Bishop propõem testar a partir de propriedades formais, com oráculo gerado da especificação. Em 2007, Pacheco e colegas propõem gerar testes de forma aleatória guiada por feedback, com contratos genéricos como oráculo. Dez anos separam os artigos: o oráculo ficou genérico e a geração de dados ficou automática. O jqwik não implementa a técnica de Fink e Bishop, mas usa a mesma ideia de propriedade como especificação. Como contraste, 15 testes de exemplo.</a:t>
+              <a:t>Eduardo (0:50). Em 1997, Fink e Bishop propõem testar a partir de propriedades formais, com oráculo gerado da especificação. Em 2007, Pacheco e colegas propõem gerar testes de forma aleatória guiada por feedback, com contratos genéricos como oráculo. Os dois usam a especificação como oráculo, com ênfases diferentes: Fink e Bishop concentram o esforço na análise do programa e deixam a escolha dos dados ao testador; Pacheco e colegas concentram o esforço na geração automática de entradas. Um não substitui o outro. O jqwik não implementa a técnica de Fink e Bishop, mas usa a mesma ideia de propriedade como especificação. Como contraste, 15 testes de exemplo.</a:t>
             </a:r>
             <a:endParaRPr lang="en-US" dirty="0"/>
           </a:p>
@@ -1177,7 +1177,7 @@
           <a:p>
             <a:r>
               <a:rPr lang="en-US" dirty="0"/>
-              <a:t>Fernando (1:10). No código correto tudo passou: 917 testes e nenhuma violação. Depois injetamos cinco defeitos. O defeito de overflow, M4, só foi detectado por exemplo e pelo jqwik; o Randoop não achou em nenhuma das quatro sementes, porque nenhum contrato fala de aritmética. O defeito no compareTo mostra o contrário: as propriedades de faixa pequena não viram, e só a de faixa larga viu. O M5, hashCode só do numerador, ninguém detecta: é um mutante equivalente em relação aos contratos.</a:t>
+              <a:t>Fernando (1:10). No código correto tudo passou: 1.500 testes e nenhuma violação. Depois injetamos cinco defeitos. O defeito de overflow, M4, só foi detectado por exemplo e pelo jqwik; o Randoop não achou em nenhuma das quatro sementes, porque nenhum contrato fala de aritmética. O defeito no compareTo mostra o contrário: as propriedades de faixa pequena não viram, e só a de faixa larga viu. O M5, hashCode só do numerador, ninguém detecta: ele preserva o contrato de igualdade e hashCode, então não é um defeito escapando.</a:t>
             </a:r>
             <a:endParaRPr lang="en-US" dirty="0"/>
           </a:p>
@@ -4685,7 +4685,7 @@
       </p:sp>
       <p:sp>
         <p:nvSpPr>
-          <p:cNvPr id="14" name="Círculo de evolução"/>
+          <p:cNvPr id="14" name="Círculo de comparação"/>
           <p:cNvSpPr/>
           <p:nvPr/>
         </p:nvSpPr>
@@ -4710,7 +4710,7 @@
       </p:sp>
       <p:sp>
         <p:nvSpPr>
-          <p:cNvPr id="15" name="Seta de evolução"/>
+          <p:cNvPr id="15" name="Símbolo de comparação"/>
           <p:cNvSpPr txBox="1"/>
           <p:nvPr/>
         </p:nvSpPr>
@@ -4738,7 +4738,7 @@
                   <a:schemeClr val="tx1"/>
                 </a:solidFill>
               </a:rPr>
-              <a:t>→</a:t>
+              <a:t>×</a:t>
             </a:r>
             <a:endParaRPr lang="en-US" sz="2200" dirty="0"/>
           </a:p>
@@ -5712,7 +5712,7 @@
       </p:sp>
       <p:sp>
         <p:nvSpPr>
-          <p:cNvPr id="27" name="Estatística 884"/>
+          <p:cNvPr id="27" name="Estatística 1467"/>
           <p:cNvSpPr/>
           <p:nvPr/>
         </p:nvSpPr>
@@ -5746,14 +5746,14 @@
       </p:sp>
       <p:sp>
         <p:nvSpPr>
-          <p:cNvPr id="28" name="Número 884"/>
+          <p:cNvPr id="28" name="Número 1467"/>
           <p:cNvSpPr txBox="1"/>
           <p:nvPr/>
         </p:nvSpPr>
         <p:spPr>
           <a:xfrm>
             <a:off x="5852160" y="1965960"/>
-            <a:ext cx="1097280" cy="777240"/>
+            <a:ext cx="1325880" cy="777240"/>
           </a:xfrm>
           <a:prstGeom prst="rect">
             <a:avLst/>
@@ -5777,7 +5777,7 @@
                 <a:ea typeface="Cambria" pitchFamily="34" charset="-122"/>
                 <a:cs typeface="Cambria" pitchFamily="34" charset="-120"/>
               </a:rPr>
-              <a:t>884</a:t>
+              <a:t>1.467</a:t>
             </a:r>
             <a:endParaRPr lang="en-US" sz="3000" dirty="0"/>
           </a:p>
@@ -5785,14 +5785,14 @@
       </p:sp>
       <p:sp>
         <p:nvSpPr>
-          <p:cNvPr id="29" name="Legenda 884"/>
+          <p:cNvPr id="29" name="Legenda 1467"/>
           <p:cNvSpPr txBox="1"/>
           <p:nvPr/>
         </p:nvSpPr>
         <p:spPr>
           <a:xfrm>
-            <a:off x="6949440" y="1965960"/>
-            <a:ext cx="1645920" cy="777240"/>
+            <a:off x="7223760" y="1965960"/>
+            <a:ext cx="1371600" cy="777240"/>
           </a:xfrm>
           <a:prstGeom prst="rect">
             <a:avLst/>
@@ -5813,7 +5813,7 @@
                   <a:schemeClr val="tx1"/>
                 </a:solidFill>
               </a:rPr>
-              <a:t>testes de regressão, 0 violações no código correto</a:t>
+              <a:t>testes de regressão, 0 reveladores de erro</a:t>
             </a:r>
             <a:endParaRPr lang="en-US" sz="1100" dirty="0"/>
           </a:p>
@@ -5821,7 +5821,7 @@
       </p:sp>
       <p:sp>
         <p:nvSpPr>
-          <p:cNvPr id="30" name="Estatística 1674"/>
+          <p:cNvPr id="30" name="Estatística 1500"/>
           <p:cNvSpPr/>
           <p:nvPr/>
         </p:nvSpPr>
@@ -5855,14 +5855,14 @@
       </p:sp>
       <p:sp>
         <p:nvSpPr>
-          <p:cNvPr id="31" name="Número 1674"/>
+          <p:cNvPr id="31" name="Número 1500"/>
           <p:cNvSpPr txBox="1"/>
           <p:nvPr/>
         </p:nvSpPr>
         <p:spPr>
           <a:xfrm>
             <a:off x="5852160" y="2852928"/>
-            <a:ext cx="1188720" cy="777240"/>
+            <a:ext cx="1325880" cy="777240"/>
           </a:xfrm>
           <a:prstGeom prst="rect">
             <a:avLst/>
@@ -5886,7 +5886,7 @@
                 <a:ea typeface="Cambria" pitchFamily="34" charset="-122"/>
                 <a:cs typeface="Cambria" pitchFamily="34" charset="-120"/>
               </a:rPr>
-              <a:t>1.674</a:t>
+              <a:t>1.500</a:t>
             </a:r>
             <a:endParaRPr lang="en-US" sz="2600" dirty="0"/>
           </a:p>
@@ -5894,14 +5894,14 @@
       </p:sp>
       <p:sp>
         <p:nvSpPr>
-          <p:cNvPr id="32" name="Legenda 1674"/>
+          <p:cNvPr id="32" name="Legenda 1500"/>
           <p:cNvSpPr txBox="1"/>
           <p:nvPr/>
         </p:nvSpPr>
         <p:spPr>
           <a:xfrm>
-            <a:off x="7086600" y="2852928"/>
-            <a:ext cx="1508760" cy="777240"/>
+            <a:off x="7223760" y="2852928"/>
+            <a:ext cx="1371600" cy="777240"/>
           </a:xfrm>
           <a:prstGeom prst="rect">
             <a:avLst/>
@@ -5922,7 +5922,7 @@
                   <a:schemeClr val="tx1"/>
                 </a:solidFill>
               </a:rPr>
-              <a:t>sequências em 60 s, semente 42</a:t>
+              <a:t>testes no total, 0 falhas (60 s, semente 42)</a:t>
             </a:r>
             <a:endParaRPr lang="en-US" sz="1100" dirty="0"/>
           </a:p>
@@ -6634,7 +6634,7 @@
                   <a:schemeClr val="tx1"/>
                 </a:solidFill>
               </a:rPr>
-              <a:t>P13: 3.949 operações verificadas</a:t>
+              <a:t>P13: 3.948 operações verificadas</a:t>
             </a:r>
             <a:endParaRPr lang="en-US" sz="1300" dirty="0"/>
           </a:p>
@@ -6711,7 +6711,7 @@
                   <a:schemeClr val="tx1"/>
                 </a:solidFill>
               </a:rPr>
-              <a:t>86% sem overflow (3.390)</a:t>
+              <a:t>86% sem overflow (3.409)</a:t>
             </a:r>
             <a:endParaRPr lang="en-US" sz="1100" dirty="0"/>
           </a:p>
@@ -6772,7 +6772,7 @@
                   <a:schemeClr val="tx1"/>
                 </a:solidFill>
               </a:rPr>
-              <a:t>14% ArithmeticException (559)</a:t>
+              <a:t>14% ArithmeticException (539)</a:t>
             </a:r>
             <a:endParaRPr lang="en-US" sz="1100" dirty="0"/>
           </a:p>
@@ -7015,7 +7015,7 @@
                   <a:schemeClr val="bg1"/>
                 </a:solidFill>
               </a:rPr>
-              <a:t>Código correto: 15 exemplos + 18 propriedades + 884 testes do Randoop = 917 testes, 0 falhas</a:t>
+              <a:t>Código correto: 15 exemplos + 18 propriedades + 1.467 testes do Randoop = 1.500 testes, 0 falhas</a:t>
             </a:r>
             <a:endParaRPr lang="en-US" sz="1300" dirty="0"/>
           </a:p>
@@ -7064,7 +7064,7 @@
                             <a:srgbClr val="FFFFFF"/>
                           </a:solidFill>
                         </a:rPr>
-                        <a:t>Defeito injetado</a:t>
+                        <a:t>Mutação</a:t>
                       </a:r>
                       <a:endParaRPr lang="en-US" sz="1200" dirty="0"/>
                     </a:p>
@@ -7493,7 +7493,7 @@
                             <a:srgbClr val="1E6B45"/>
                           </a:solidFill>
                         </a:rPr>
-                        <a:t>sim (1 teste)</a:t>
+                        <a:t>sim (18 testes)</a:t>
                       </a:r>
                       <a:endParaRPr lang="en-US" sz="1150" dirty="0"/>
                     </a:p>
@@ -7739,7 +7739,7 @@
                             <a:srgbClr val="1E6B45"/>
                           </a:solidFill>
                         </a:rPr>
-                        <a:t>sim (6 testes)</a:t>
+                        <a:t>sim (16 testes)</a:t>
                       </a:r>
                       <a:endParaRPr lang="en-US" sz="1150" dirty="0"/>
                     </a:p>
@@ -7985,7 +7985,7 @@
                             <a:srgbClr val="1E6B45"/>
                           </a:solidFill>
                         </a:rPr>
-                        <a:t>sim (1 teste)</a:t>
+                        <a:t>sim (4 testes)</a:t>
                       </a:r>
                       <a:endParaRPr lang="en-US" sz="1150" dirty="0"/>
                     </a:p>
@@ -8559,7 +8559,7 @@
                   <a:schemeClr val="accent5"/>
                 </a:solidFill>
               </a:rPr>
-              <a:t>M5 é mutante equivalente em relação aos contratos. Sementes 1 a 3 do Randoop: M1 sempre detectado, M4 nunca.</a:t>
+              <a:t>M5 preserva o contrato (não é defeito). Sementes 1 a 3 do Randoop: M1 sempre detectado, M4 nunca.</a:t>
             </a:r>
             <a:endParaRPr lang="en-US" sz="1100" dirty="0"/>
           </a:p>
@@ -9031,7 +9031,7 @@
                   <a:schemeClr val="tx1"/>
                 </a:solidFill>
               </a:rPr>
-              <a:t>61 execuções excepcionais em 20,9 milhões</a:t>
+              <a:t>Pelo artigo, sequências com exceção não são estendidas</a:t>
             </a:r>
             <a:endParaRPr lang="en-US" sz="1250" dirty="0"/>
           </a:p>
@@ -9049,7 +9049,7 @@
                   <a:schemeClr val="tx1"/>
                 </a:solidFill>
               </a:rPr>
-              <a:t>O Randoop não as estende; só P12 e P13 conferem a exceção exigida</a:t>
+              <a:t>O experimento não isola essa causa</a:t>
             </a:r>
             <a:endParaRPr lang="en-US" sz="1250" dirty="0"/>
           </a:p>
@@ -9186,7 +9186,7 @@
                   <a:schemeClr val="tx1"/>
                 </a:solidFill>
               </a:rPr>
-              <a:t>5 defeitos injetados à mão</a:t>
+              <a:t>5 mutações à mão, 4 com defeitos</a:t>
             </a:r>
             <a:endParaRPr lang="en-US" sz="1250" dirty="0"/>
           </a:p>

</xml_diff>